<commit_message>
Add poster metrics JSON file with performance data for different strategies
</commit_message>
<xml_diff>
--- a/docs/poster/IoT_Energy_Optimization_Poster.pptx
+++ b/docs/poster/IoT_Energy_Optimization_Poster.pptx
@@ -15964,7 +15964,7 @@
                 </a:solidFill>
                 <a:latin typeface="Tahoma"/>
               </a:rPr>
-              <a:t>نودهای حسگر IoT معمولاً با باتری محدود کار می‌کنند. ارسال مداوم عمر شبکه را کم می‌کند و خواب بیش از حد کیفیت پایش را پایین می‌آورد.</a:t>
+              <a:t>نودهای حسگر IoT با باتری محدود کار می‌کنند. ارسال مداوم عمر شبکه را کم و خواب بیش از حد کیفیت پایش را پایین می‌آورد.</a:t>
             </a:r>
             <a:endParaRPr lang="en-US"/>
           </a:p>
@@ -15981,7 +15981,7 @@
                 </a:solidFill>
                 <a:latin typeface="Tahoma"/>
               </a:rPr>
-              <a:t>اتصالات جهانی IoT از حدود ۲۱ میلیارد (۲۰۲۵) به حدود ۴۸ میلیارد (۲۰۳۵) می‌رسد [1]. بنابراین تصمیم هوشمند بین Transmit و Sleep ضروری است.</a:t>
+              <a:t>هدف: تصمیم هوشمند Transmit/Sleep برای تعادل بین انرژی، تحویل بسته و تازگی داده (AoI).</a:t>
             </a:r>
           </a:p>
         </p:txBody>
@@ -16054,7 +16054,7 @@
                 </a:solidFill>
                 <a:latin typeface="Tahoma"/>
               </a:rPr>
-              <a:t>تنظیمات: ۳ نود | افق ۵۰ گام | آموزش ۸۰۰۰ گام | میانگین ۵ اپیزود</a:t>
+              <a:t>تنظیمات ران: ۳ نود | افق ۵۰ | آموزش ۶۰۰۰ | میانگین ۵ اپیزود | seed=42</a:t>
             </a:r>
             <a:endParaRPr lang="en-US" dirty="0"/>
           </a:p>
@@ -16071,7 +16071,7 @@
                 </a:solidFill>
                 <a:latin typeface="Tahoma"/>
               </a:rPr>
-              <a:t>Always Transmit → Lifetime 17 | Packets 48 | Energy 0.00</a:t>
+              <a:t>Transmit → Life 15.4 | Pkt 26.6 | PDR 0.70</a:t>
             </a:r>
           </a:p>
           <a:p>
@@ -16087,7 +16087,7 @@
                 </a:solidFill>
                 <a:latin typeface="Tahoma"/>
               </a:rPr>
-              <a:t>Always Sleep → Lifetime 50 | Packets 0 | Energy 2.85</a:t>
+              <a:t>Sleep → Life 50.0 | Pkt 0.0 | AoI 50.0</a:t>
             </a:r>
           </a:p>
           <a:p>
@@ -16103,7 +16103,7 @@
                 </a:solidFill>
                 <a:latin typeface="Tahoma"/>
               </a:rPr>
-              <a:t>Random → Lifetime 38.6 | Packets 48 | Energy 0.00</a:t>
+              <a:t>Random → Life 33.0 | Pkt 26.2 | PDR 0.70</a:t>
             </a:r>
           </a:p>
           <a:p>
@@ -16119,7 +16119,7 @@
                 </a:solidFill>
                 <a:latin typeface="Tahoma"/>
               </a:rPr>
-              <a:t>DQN → Lifetime 50 | Packets 42 | Energy 0.37</a:t>
+              <a:t>DQN → Life 49.4 | Pkt 29.4 | PDR 0.76 | AoI 16.2</a:t>
             </a:r>
           </a:p>
           <a:p>
@@ -16135,7 +16135,7 @@
                 </a:solidFill>
                 <a:latin typeface="Tahoma"/>
               </a:rPr>
-              <a:t>پیام: DQN عمر شبکه را حفظ می‌کند و هم‌زمان داده تحویل می‌دهد.</a:t>
+              <a:t>پیام: DQN بهترین مصالحه عمر شبکه، تحویل بسته و تازگی داده را دارد.</a:t>
             </a:r>
           </a:p>
         </p:txBody>
@@ -16169,7 +16169,7 @@
                 </a:solidFill>
                 <a:latin typeface="Tahoma"/>
               </a:rPr>
-              <a:t>نتایج کلیدی</a:t>
+              <a:t>نتایج کلیدی (ران نهایی)</a:t>
             </a:r>
             <a:endParaRPr lang="en-US" dirty="0"/>
           </a:p>
@@ -16208,7 +16208,7 @@
                 </a:solidFill>
                 <a:latin typeface="Tahoma"/>
               </a:rPr>
-              <a:t>• شبیه‌سازی شبکه IoT با مدل انرژی</a:t>
+              <a:t>• شبیه‌ساز IoT + انرژی فاصله‌آگاه + افت بسته</a:t>
             </a:r>
             <a:endParaRPr lang="en-US"/>
           </a:p>
@@ -16225,7 +16225,7 @@
                 </a:solidFill>
                 <a:latin typeface="Tahoma"/>
               </a:rPr>
-              <a:t>• آموزش عامل DQN برای تصمیم Transmit / Sleep</a:t>
+              <a:t>• محیط Gymnasium و آموزش DQN</a:t>
             </a:r>
           </a:p>
           <a:p>
@@ -16241,7 +16241,7 @@
                 </a:solidFill>
                 <a:latin typeface="Tahoma"/>
               </a:rPr>
-              <a:t>• مقایسه با Always Transmit، Always Sleep و Random</a:t>
+              <a:t>• مقایسه با Transmit / Sleep / Random</a:t>
             </a:r>
           </a:p>
           <a:p>
@@ -16257,7 +16257,23 @@
                 </a:solidFill>
                 <a:latin typeface="Tahoma"/>
               </a:rPr>
-              <a:t>• داشبورد تعاملی با Streamlit</a:t>
+              <a:t>• داشبورد Streamlit</a:t>
+            </a:r>
+          </a:p>
+          <a:p>
+            <a:pPr algn="r">
+              <a:spcAft>
+                <a:spcPts val="600"/>
+              </a:spcAft>
+            </a:pPr>
+            <a:r>
+              <a:rPr sz="1200" b="0">
+                <a:solidFill>
+                  <a:srgbClr val="1A2332"/>
+                </a:solidFill>
+                <a:latin typeface="Tahoma"/>
+              </a:rPr>
+              <a:t>معماری: UI → Simulation → RL → Analytics</a:t>
             </a:r>
           </a:p>
         </p:txBody>
@@ -16291,7 +16307,7 @@
                 </a:solidFill>
                 <a:latin typeface="Tahoma"/>
               </a:rPr>
-              <a:t>اهداف پروژه</a:t>
+              <a:t>اهداف و معماری</a:t>
             </a:r>
             <a:endParaRPr lang="en-US" dirty="0"/>
           </a:p>
@@ -16365,7 +16381,7 @@
                 </a:solidFill>
                 <a:latin typeface="Tahoma"/>
               </a:rPr>
-              <a:t>• حالت نود: active / sleep / dead</a:t>
+              <a:t>• هزینه TX وابسته به فاصله تا Gateway</a:t>
             </a:r>
             <a:endParaRPr lang="en-US"/>
           </a:p>
@@ -16382,7 +16398,7 @@
                 </a:solidFill>
                 <a:latin typeface="Tahoma"/>
               </a:rPr>
-              <a:t>• مشاهده: انرژی نودها + زنده بودن + زمان</a:t>
+              <a:t>• کانال ساده: احتمال تحویل با فاصله کم می‌شود</a:t>
             </a:r>
           </a:p>
           <a:p>
@@ -16398,7 +16414,7 @@
                 </a:solidFill>
                 <a:latin typeface="Tahoma"/>
               </a:rPr>
-              <a:t>• عمل: Sleep یا Transmit برای هر نود</a:t>
+              <a:t>• معیار AoI برای تازگی اطلاعات</a:t>
             </a:r>
           </a:p>
           <a:p>
@@ -16414,7 +16430,7 @@
                 </a:solidFill>
                 <a:latin typeface="Tahoma"/>
               </a:rPr>
-              <a:t>• پاداش: بسته و عمر بیشتر − مصرف انرژی − مرگ نود</a:t>
+              <a:t>• پاداش: بسته/عمر بیشتر − انرژی − AoI − drop</a:t>
             </a:r>
           </a:p>
           <a:p>
@@ -16430,7 +16446,7 @@
                 </a:solidFill>
                 <a:latin typeface="Tahoma"/>
               </a:rPr>
-              <a:t>• ابزار: Python، Gymnasium، Stable-Baselines3، Streamlit</a:t>
+              <a:t>• ابزار: Python، Gymnasium، SB3، Streamlit</a:t>
             </a:r>
           </a:p>
         </p:txBody>
@@ -16503,7 +16519,7 @@
                 </a:solidFill>
                 <a:latin typeface="Tahoma"/>
               </a:rPr>
-              <a:t>DQN مصالحه‌ای میان تحویل بسته و حفظ انرژی یاد می‌گیرد. داشبورد امکان آموزش، اجرا و مقایسه سیاست‌ها را فراهم می‌کند.</a:t>
+              <a:t>با مدل فاصله/افت بسته/AoI، DQN از سیاست‌های ثابت بهتر مصالحه می‌کند.</a:t>
             </a:r>
             <a:endParaRPr lang="en-US"/>
           </a:p>
@@ -16520,7 +16536,7 @@
                 </a:solidFill>
                 <a:latin typeface="Tahoma"/>
               </a:rPr>
-              <a:t>آینده: Multi-Agent RL، مدل کانال واقعی، مسیریابی چندگامه، سخت‌افزار.</a:t>
+              <a:t>آینده: آموزش بهتر برای n بزرگ‌تر، Multi-Agent RL، سخت‌افزار واقعی.</a:t>
             </a:r>
           </a:p>
           <a:p>
@@ -16712,8 +16728,8 @@
         </p:blipFill>
         <p:spPr>
           <a:xfrm>
-            <a:off x="6389292" y="7400000"/>
-            <a:ext cx="2885148" cy="9400000"/>
+            <a:off x="21531244" y="7150000"/>
+            <a:ext cx="828712" cy="2700000"/>
           </a:xfrm>
           <a:prstGeom prst="rect">
             <a:avLst/>
@@ -16736,8 +16752,8 @@
         </p:blipFill>
         <p:spPr>
           <a:xfrm>
-            <a:off x="15213167" y="7400000"/>
-            <a:ext cx="13464865" cy="9400000"/>
+            <a:off x="9150368" y="10030000"/>
+            <a:ext cx="4454864" cy="3110000"/>
           </a:xfrm>
           <a:prstGeom prst="rect">
             <a:avLst/>
@@ -16760,8 +16776,56 @@
         </p:blipFill>
         <p:spPr>
           <a:xfrm>
-            <a:off x="29127466" y="8698467"/>
-            <a:ext cx="13863733" cy="6803065"/>
+            <a:off x="29344519" y="10030000"/>
+            <a:ext cx="6337762" cy="3110000"/>
+          </a:xfrm>
+          <a:prstGeom prst="rect">
+            <a:avLst/>
+          </a:prstGeom>
+        </p:spPr>
+      </p:pic>
+      <p:pic>
+        <p:nvPicPr>
+          <p:cNvPr id="54" name="Picture 53" descr="aoi_curves.png"/>
+          <p:cNvPicPr>
+            <a:picLocks noChangeAspect="1"/>
+          </p:cNvPicPr>
+          <p:nvPr/>
+        </p:nvPicPr>
+        <p:blipFill>
+          <a:blip r:embed="rId6"/>
+          <a:stretch>
+            <a:fillRect/>
+          </a:stretch>
+        </p:blipFill>
+        <p:spPr>
+          <a:xfrm>
+            <a:off x="8208919" y="13320000"/>
+            <a:ext cx="6337762" cy="3110000"/>
+          </a:xfrm>
+          <a:prstGeom prst="rect">
+            <a:avLst/>
+          </a:prstGeom>
+        </p:spPr>
+      </p:pic>
+      <p:pic>
+        <p:nvPicPr>
+          <p:cNvPr id="55" name="Picture 54" descr="packets_curves.png"/>
+          <p:cNvPicPr>
+            <a:picLocks noChangeAspect="1"/>
+          </p:cNvPicPr>
+          <p:nvPr/>
+        </p:nvPicPr>
+        <p:blipFill>
+          <a:blip r:embed="rId7"/>
+          <a:stretch>
+            <a:fillRect/>
+          </a:stretch>
+        </p:blipFill>
+        <p:spPr>
+          <a:xfrm>
+            <a:off x="29344519" y="13320000"/>
+            <a:ext cx="6337762" cy="3110000"/>
           </a:xfrm>
           <a:prstGeom prst="rect">
             <a:avLst/>

</xml_diff>